<commit_message>
Ch1 deck: make closing slide delivery-neutral for async sections
</commit_message>
<xml_diff>
--- a/slides/ch01-communicating-in-todays-workplace.pptx
+++ b/slides/ch01-communicating-in-todays-workplace.pptx
@@ -2567,7 +2567,7 @@
           <a:lstStyle/>
           <a:p>
             <a:r>
-              <a:t>Standard closing slide pattern used across all chapter decks: practice, graded work, writing, reflection, preview.</a:t>
+              <a:t>Delivery-neutral closing slide (no 'next class' phrasing — works for asynchronous sections). Standard pattern across all chapter decks: practice, graded work, writing, reflection, preview.</a:t>
             </a:r>
           </a:p>
         </p:txBody>
@@ -17659,7 +17659,7 @@
       <p:grpSpPr/>
       <p:sp>
         <p:nvSpPr>
-          <p:cNvPr id="2" name="TextBox 1" descr="Slide title: Before next class"/>
+          <p:cNvPr id="2" name="TextBox 1" descr="Slide title: Your next steps"/>
           <p:cNvSpPr txBox="1"/>
           <p:nvPr/>
         </p:nvSpPr>
@@ -17686,7 +17686,7 @@
                 </a:solidFill>
                 <a:latin typeface="Cambria"/>
               </a:rPr>
-              <a:t>Before next class</a:t>
+              <a:t>Your next steps</a:t>
             </a:r>
           </a:p>
         </p:txBody>
@@ -17846,7 +17846,7 @@
                 </a:solidFill>
                 <a:latin typeface="Calibri"/>
               </a:rPr>
-              <a:t>Complete the Chapter 1 homework on the site; paste your completion code into the LMS assignment.</a:t>
+              <a:t>Complete the Chapter 1 homework on the site; paste your completion code into the Blackboard assignment before the weekly deadline.</a:t>
             </a:r>
           </a:p>
           <a:p>

</xml_diff>

<commit_message>
Add copyright notices to all guides, decks, and the compiled textbook
Every study guide footer, every slide footer, and the compiled
volume's title page and footer now carry an explicit copyright notice
naming the author, complementing the site's institutional-license
footer. Rebuilt all 17 guides, all 17 decks, and the 413-page
compiled volume (pagination unchanged).
</commit_message>
<xml_diff>
--- a/slides/ch01-communicating-in-todays-workplace.pptx
+++ b/slides/ch01-communicating-in-todays-workplace.pptx
@@ -6239,7 +6239,7 @@
                 </a:solidFill>
                 <a:latin typeface="Calibri"/>
               </a:rPr>
-              <a:t>BADM 225 · Chapter 1</a:t>
+              <a:t>BADM 225 · Chapter 1  ·  © Derek D. Bussan</a:t>
             </a:r>
           </a:p>
         </p:txBody>
@@ -6893,7 +6893,7 @@
                 </a:solidFill>
                 <a:latin typeface="Calibri"/>
               </a:rPr>
-              <a:t>BADM 225 · Chapter 1</a:t>
+              <a:t>BADM 225 · Chapter 1  ·  © Derek D. Bussan</a:t>
             </a:r>
           </a:p>
         </p:txBody>
@@ -7335,7 +7335,7 @@
                 </a:solidFill>
                 <a:latin typeface="Calibri"/>
               </a:rPr>
-              <a:t>BADM 225 · Chapter 1</a:t>
+              <a:t>BADM 225 · Chapter 1  ·  © Derek D. Bussan</a:t>
             </a:r>
           </a:p>
         </p:txBody>
@@ -7934,7 +7934,7 @@
                 </a:solidFill>
                 <a:latin typeface="Calibri"/>
               </a:rPr>
-              <a:t>BADM 225 · Chapter 1</a:t>
+              <a:t>BADM 225 · Chapter 1  ·  © Derek D. Bussan</a:t>
             </a:r>
           </a:p>
         </p:txBody>
@@ -8572,7 +8572,7 @@
                 </a:solidFill>
                 <a:latin typeface="Calibri"/>
               </a:rPr>
-              <a:t>BADM 225 · Chapter 1</a:t>
+              <a:t>BADM 225 · Chapter 1  ·  © Derek D. Bussan</a:t>
             </a:r>
           </a:p>
         </p:txBody>
@@ -8700,7 +8700,7 @@
                 </a:solidFill>
                 <a:latin typeface="Calibri"/>
               </a:rPr>
-              <a:t>BADM 225 · Chapter 1</a:t>
+              <a:t>BADM 225 · Chapter 1  ·  © Derek D. Bussan</a:t>
             </a:r>
           </a:p>
         </p:txBody>
@@ -8960,7 +8960,7 @@
                 </a:solidFill>
                 <a:latin typeface="Calibri"/>
               </a:rPr>
-              <a:t>BADM 225 · Chapter 1</a:t>
+              <a:t>BADM 225 · Chapter 1  ·  © Derek D. Bussan</a:t>
             </a:r>
           </a:p>
         </p:txBody>
@@ -9614,7 +9614,7 @@
                 </a:solidFill>
                 <a:latin typeface="Calibri"/>
               </a:rPr>
-              <a:t>BADM 225 · Chapter 1</a:t>
+              <a:t>BADM 225 · Chapter 1  ·  © Derek D. Bussan</a:t>
             </a:r>
           </a:p>
         </p:txBody>
@@ -10031,7 +10031,7 @@
                 </a:solidFill>
                 <a:latin typeface="Calibri"/>
               </a:rPr>
-              <a:t>BADM 225 · Chapter 1</a:t>
+              <a:t>BADM 225 · Chapter 1  ·  © Derek D. Bussan</a:t>
             </a:r>
           </a:p>
         </p:txBody>
@@ -10777,7 +10777,7 @@
                 </a:solidFill>
                 <a:latin typeface="Calibri"/>
               </a:rPr>
-              <a:t>BADM 225 · Chapter 1</a:t>
+              <a:t>BADM 225 · Chapter 1  ·  © Derek D. Bussan</a:t>
             </a:r>
           </a:p>
         </p:txBody>
@@ -10905,7 +10905,7 @@
                 </a:solidFill>
                 <a:latin typeface="Calibri"/>
               </a:rPr>
-              <a:t>BADM 225 · Chapter 1</a:t>
+              <a:t>BADM 225 · Chapter 1  ·  © Derek D. Bussan</a:t>
             </a:r>
           </a:p>
         </p:txBody>
@@ -11260,7 +11260,7 @@
                 </a:solidFill>
                 <a:latin typeface="Calibri"/>
               </a:rPr>
-              <a:t>BADM 225 · Chapter 1</a:t>
+              <a:t>BADM 225 · Chapter 1  ·  © Derek D. Bussan</a:t>
             </a:r>
           </a:p>
         </p:txBody>
@@ -11928,7 +11928,7 @@
                 </a:solidFill>
                 <a:latin typeface="Calibri"/>
               </a:rPr>
-              <a:t>BADM 225 · Chapter 1</a:t>
+              <a:t>BADM 225 · Chapter 1  ·  © Derek D. Bussan</a:t>
             </a:r>
           </a:p>
         </p:txBody>
@@ -12254,7 +12254,7 @@
                 </a:solidFill>
                 <a:latin typeface="Calibri"/>
               </a:rPr>
-              <a:t>BADM 225 · Chapter 1</a:t>
+              <a:t>BADM 225 · Chapter 1  ·  © Derek D. Bussan</a:t>
             </a:r>
           </a:p>
         </p:txBody>
@@ -12774,7 +12774,7 @@
                 </a:solidFill>
                 <a:latin typeface="Calibri"/>
               </a:rPr>
-              <a:t>BADM 225 · Chapter 1</a:t>
+              <a:t>BADM 225 · Chapter 1  ·  © Derek D. Bussan</a:t>
             </a:r>
           </a:p>
         </p:txBody>
@@ -12902,7 +12902,7 @@
                 </a:solidFill>
                 <a:latin typeface="Calibri"/>
               </a:rPr>
-              <a:t>BADM 225 · Chapter 1</a:t>
+              <a:t>BADM 225 · Chapter 1  ·  © Derek D. Bussan</a:t>
             </a:r>
           </a:p>
         </p:txBody>
@@ -13344,7 +13344,7 @@
                 </a:solidFill>
                 <a:latin typeface="Calibri"/>
               </a:rPr>
-              <a:t>BADM 225 · Chapter 1</a:t>
+              <a:t>BADM 225 · Chapter 1  ·  © Derek D. Bussan</a:t>
             </a:r>
           </a:p>
         </p:txBody>
@@ -13743,7 +13743,7 @@
                 </a:solidFill>
                 <a:latin typeface="Calibri"/>
               </a:rPr>
-              <a:t>BADM 225 · Chapter 1</a:t>
+              <a:t>BADM 225 · Chapter 1  ·  © Derek D. Bussan</a:t>
             </a:r>
           </a:p>
         </p:txBody>
@@ -13871,7 +13871,7 @@
                 </a:solidFill>
                 <a:latin typeface="Calibri"/>
               </a:rPr>
-              <a:t>BADM 225 · Chapter 1</a:t>
+              <a:t>BADM 225 · Chapter 1  ·  © Derek D. Bussan</a:t>
             </a:r>
           </a:p>
         </p:txBody>
@@ -14331,7 +14331,7 @@
                 </a:solidFill>
                 <a:latin typeface="Calibri"/>
               </a:rPr>
-              <a:t>BADM 225 · Chapter 1</a:t>
+              <a:t>BADM 225 · Chapter 1  ·  © Derek D. Bussan</a:t>
             </a:r>
           </a:p>
         </p:txBody>
@@ -14891,7 +14891,7 @@
                 </a:solidFill>
                 <a:latin typeface="Calibri"/>
               </a:rPr>
-              <a:t>BADM 225 · Chapter 1</a:t>
+              <a:t>BADM 225 · Chapter 1  ·  © Derek D. Bussan</a:t>
             </a:r>
           </a:p>
         </p:txBody>
@@ -15212,7 +15212,7 @@
                 </a:solidFill>
                 <a:latin typeface="Calibri"/>
               </a:rPr>
-              <a:t>BADM 225 · Chapter 1</a:t>
+              <a:t>BADM 225 · Chapter 1  ·  © Derek D. Bussan</a:t>
             </a:r>
           </a:p>
         </p:txBody>
@@ -15538,7 +15538,7 @@
                 </a:solidFill>
                 <a:latin typeface="Calibri"/>
               </a:rPr>
-              <a:t>BADM 225 · Chapter 1</a:t>
+              <a:t>BADM 225 · Chapter 1  ·  © Derek D. Bussan</a:t>
             </a:r>
           </a:p>
         </p:txBody>
@@ -15864,7 +15864,7 @@
                 </a:solidFill>
                 <a:latin typeface="Calibri"/>
               </a:rPr>
-              <a:t>BADM 225 · Chapter 1</a:t>
+              <a:t>BADM 225 · Chapter 1  ·  © Derek D. Bussan</a:t>
             </a:r>
           </a:p>
         </p:txBody>
@@ -16185,7 +16185,7 @@
                 </a:solidFill>
                 <a:latin typeface="Calibri"/>
               </a:rPr>
-              <a:t>BADM 225 · Chapter 1</a:t>
+              <a:t>BADM 225 · Chapter 1  ·  © Derek D. Bussan</a:t>
             </a:r>
           </a:p>
         </p:txBody>
@@ -16506,7 +16506,7 @@
                 </a:solidFill>
                 <a:latin typeface="Calibri"/>
               </a:rPr>
-              <a:t>BADM 225 · Chapter 1</a:t>
+              <a:t>BADM 225 · Chapter 1  ·  © Derek D. Bussan</a:t>
             </a:r>
           </a:p>
         </p:txBody>
@@ -17321,7 +17321,7 @@
                 </a:solidFill>
                 <a:latin typeface="Calibri"/>
               </a:rPr>
-              <a:t>BADM 225 · Chapter 1</a:t>
+              <a:t>BADM 225 · Chapter 1  ·  © Derek D. Bussan</a:t>
             </a:r>
           </a:p>
         </p:txBody>
@@ -17597,7 +17597,7 @@
                 </a:solidFill>
                 <a:latin typeface="Calibri"/>
               </a:rPr>
-              <a:t>BADM 225 · Chapter 1</a:t>
+              <a:t>BADM 225 · Chapter 1  ·  © Derek D. Bussan</a:t>
             </a:r>
           </a:p>
         </p:txBody>
@@ -17690,7 +17690,7 @@
                 </a:solidFill>
                 <a:latin typeface="Calibri"/>
               </a:rPr>
-              <a:t>BADM 225 · Chapter 1</a:t>
+              <a:t>BADM 225 · Chapter 1  ·  © Derek D. Bussan</a:t>
             </a:r>
           </a:p>
         </p:txBody>
@@ -18089,7 +18089,7 @@
                 </a:solidFill>
                 <a:latin typeface="Calibri"/>
               </a:rPr>
-              <a:t>BADM 225 · Chapter 1</a:t>
+              <a:t>BADM 225 · Chapter 1  ·  © Derek D. Bussan</a:t>
             </a:r>
           </a:p>
         </p:txBody>
@@ -18217,7 +18217,7 @@
                 </a:solidFill>
                 <a:latin typeface="Calibri"/>
               </a:rPr>
-              <a:t>BADM 225 · Chapter 1</a:t>
+              <a:t>BADM 225 · Chapter 1  ·  © Derek D. Bussan</a:t>
             </a:r>
           </a:p>
         </p:txBody>
@@ -18871,7 +18871,7 @@
                 </a:solidFill>
                 <a:latin typeface="Calibri"/>
               </a:rPr>
-              <a:t>BADM 225 · Chapter 1</a:t>
+              <a:t>BADM 225 · Chapter 1  ·  © Derek D. Bussan</a:t>
             </a:r>
           </a:p>
         </p:txBody>
@@ -19349,7 +19349,7 @@
                 </a:solidFill>
                 <a:latin typeface="Calibri"/>
               </a:rPr>
-              <a:t>BADM 225 · Chapter 1</a:t>
+              <a:t>BADM 225 · Chapter 1  ·  © Derek D. Bussan</a:t>
             </a:r>
           </a:p>
         </p:txBody>
@@ -19840,7 +19840,7 @@
                 </a:solidFill>
                 <a:latin typeface="Calibri"/>
               </a:rPr>
-              <a:t>BADM 225 · Chapter 1</a:t>
+              <a:t>BADM 225 · Chapter 1  ·  © Derek D. Bussan</a:t>
             </a:r>
           </a:p>
         </p:txBody>
@@ -20239,7 +20239,7 @@
                 </a:solidFill>
                 <a:latin typeface="Calibri"/>
               </a:rPr>
-              <a:t>BADM 225 · Chapter 1</a:t>
+              <a:t>BADM 225 · Chapter 1  ·  © Derek D. Bussan</a:t>
             </a:r>
           </a:p>
         </p:txBody>

</xml_diff>